<commit_message>
Rebrand to Arthashastra Learning
</commit_message>
<xml_diff>
--- a/01-what-is-an-agent/slides/ep01-what-is-an-agent.pptx
+++ b/01-what-is-an-agent/slides/ep01-what-is-an-agent.pptx
@@ -2104,7 +2104,7 @@
                 <a:ea typeface="Calibri" pitchFamily="34" charset="-122"/>
                 <a:cs typeface="Calibri" pitchFamily="34" charset="-120"/>
               </a:rPr>
-              <a:t>THE AGENTIC ENTERPRISE  ·  EPISODE 1</a:t>
+              <a:t>ARTHASHASTRA LEARNING  ·  THE AGENTIC ENTERPRISE  ·  EP 1</a:t>
             </a:r>
             <a:endParaRPr lang="en-US" sz="1200" dirty="0"/>
           </a:p>
@@ -2238,7 +2238,7 @@
                 <a:ea typeface="Calibri" pitchFamily="34" charset="-122"/>
                 <a:cs typeface="Calibri" pitchFamily="34" charset="-120"/>
               </a:rPr>
-              <a:t>Delivery Head, AI &amp; Data Platforms · Founder, TradeNeo</a:t>
+              <a:t>Founder, Arthashastra Intelligence · Delivery Head, AI &amp; Data Platforms</a:t>
             </a:r>
             <a:endParaRPr lang="en-US" sz="1200" dirty="0"/>
           </a:p>
@@ -5348,7 +5348,7 @@
                 <a:ea typeface="Calibri" pitchFamily="34" charset="-122"/>
                 <a:cs typeface="Calibri" pitchFamily="34" charset="-120"/>
               </a:rPr>
-              <a:t>The Agentic Enterprise · one episode a week</a:t>
+              <a:t>Arthashastra Learning · one episode a week</a:t>
             </a:r>
             <a:endParaRPr lang="en-US" sz="1000" dirty="0"/>
           </a:p>
@@ -6034,7 +6034,7 @@
                 <a:ea typeface="Calibri" pitchFamily="34" charset="-122"/>
                 <a:cs typeface="Calibri" pitchFamily="34" charset="-120"/>
               </a:rPr>
-              <a:t>Harsha Pasumarthi · The Agentic Enterprise</a:t>
+              <a:t>Harsha Pasumarthi · Arthashastra Learning</a:t>
             </a:r>
             <a:endParaRPr lang="en-US" sz="1000" dirty="0"/>
           </a:p>
@@ -6675,7 +6675,7 @@
                 <a:ea typeface="Calibri" pitchFamily="34" charset="-122"/>
                 <a:cs typeface="Calibri" pitchFamily="34" charset="-120"/>
               </a:rPr>
-              <a:t>The Agentic Enterprise · Ep 1</a:t>
+              <a:t>Arthashastra Learning · The Agentic Enterprise · Ep 1</a:t>
             </a:r>
             <a:endParaRPr lang="en-US" sz="1000" dirty="0"/>
           </a:p>
@@ -7963,7 +7963,7 @@
                 <a:ea typeface="Calibri" pitchFamily="34" charset="-122"/>
                 <a:cs typeface="Calibri" pitchFamily="34" charset="-120"/>
               </a:rPr>
-              <a:t>The Agentic Enterprise · Ep 1</a:t>
+              <a:t>Arthashastra Learning · The Agentic Enterprise · Ep 1</a:t>
             </a:r>
             <a:endParaRPr lang="en-US" sz="1000" dirty="0"/>
           </a:p>
@@ -8867,7 +8867,7 @@
                 <a:ea typeface="Calibri" pitchFamily="34" charset="-122"/>
                 <a:cs typeface="Calibri" pitchFamily="34" charset="-120"/>
               </a:rPr>
-              <a:t>The Agentic Enterprise · Ep 1</a:t>
+              <a:t>Arthashastra Learning · The Agentic Enterprise · Ep 1</a:t>
             </a:r>
             <a:endParaRPr lang="en-US" sz="1000" dirty="0"/>
           </a:p>
@@ -9773,7 +9773,7 @@
                 <a:ea typeface="Calibri" pitchFamily="34" charset="-122"/>
                 <a:cs typeface="Calibri" pitchFamily="34" charset="-120"/>
               </a:rPr>
-              <a:t>The Agentic Enterprise · Ep 1</a:t>
+              <a:t>Arthashastra Learning · The Agentic Enterprise · Ep 1</a:t>
             </a:r>
             <a:endParaRPr lang="en-US" sz="1000" dirty="0"/>
           </a:p>
@@ -10441,7 +10441,7 @@
                 <a:ea typeface="Calibri" pitchFamily="34" charset="-122"/>
                 <a:cs typeface="Calibri" pitchFamily="34" charset="-120"/>
               </a:rPr>
-              <a:t>The Agentic Enterprise · Ep 1</a:t>
+              <a:t>Arthashastra Learning · The Agentic Enterprise · Ep 1</a:t>
             </a:r>
             <a:endParaRPr lang="en-US" sz="1000" dirty="0"/>
           </a:p>

</xml_diff>